<commit_message>
fix: rebuild PPTX with full-width text, images alongside text where possible
</commit_message>
<xml_diff>
--- a/notes/presentations/26-07-03/presentation-03-07-2026.pptx
+++ b/notes/presentations/26-07-03/presentation-03-07-2026.pptx
@@ -37,7 +37,6 @@
     <p:sldId id="285" r:id="rId36"/>
     <p:sldId id="286" r:id="rId37"/>
     <p:sldId id="287" r:id="rId38"/>
-    <p:sldId id="288" r:id="rId39"/>
   </p:sldIdLst>
   <p:sldSz cx="12188952" cy="6858000" type="screen4x3"/>
   <p:notesSz cx="6858000" cy="9144000"/>
@@ -3128,8 +3127,8 @@
         </p:nvSpPr>
         <p:spPr>
           <a:xfrm>
-            <a:off x="914400" y="2286000"/>
-            <a:ext cx="10058400" cy="1371600"/>
+            <a:off x="365760" y="182880"/>
+            <a:ext cx="11430000" cy="640080"/>
           </a:xfrm>
           <a:prstGeom prst="rect">
             <a:avLst/>
@@ -3143,19 +3142,11 @@
           <a:lstStyle/>
           <a:p/>
           <a:p>
-            <a:pPr algn="ctr">
-              <a:defRPr sz="4000" b="1"/>
-            </a:pPr>
-            <a:r>
-              <a:t>Differentiable Monte Carlo</a:t>
-            </a:r>
-          </a:p>
-          <a:p>
-            <a:pPr algn="ctr">
-              <a:defRPr sz="2000"/>
-            </a:pPr>
-            <a:r>
-              <a:t>Progress Update — 03 July 2026</a:t>
+            <a:pPr>
+              <a:defRPr sz="3600" b="1"/>
+            </a:pPr>
+            <a:r>
+              <a:t>Updates 03 Jul 2026</a:t>
             </a:r>
           </a:p>
         </p:txBody>
@@ -3186,8 +3177,8 @@
         </p:nvSpPr>
         <p:spPr>
           <a:xfrm>
-            <a:off x="914400" y="2286000"/>
-            <a:ext cx="10058400" cy="1371600"/>
+            <a:off x="365760" y="182880"/>
+            <a:ext cx="11430000" cy="640080"/>
           </a:xfrm>
           <a:prstGeom prst="rect">
             <a:avLst/>
@@ -3201,19 +3192,11 @@
           <a:lstStyle/>
           <a:p/>
           <a:p>
-            <a:pPr algn="ctr">
-              <a:defRPr sz="4000" b="1"/>
-            </a:pPr>
-            <a:r>
-              <a:t>Exploratory Data Analysis</a:t>
-            </a:r>
-          </a:p>
-          <a:p>
-            <a:pPr algn="ctr">
-              <a:defRPr sz="2000"/>
-            </a:pPr>
-            <a:r>
-              <a:t>Understanding the experimental data</a:t>
+            <a:pPr>
+              <a:defRPr sz="3600" b="1"/>
+            </a:pPr>
+            <a:r>
+              <a:t>EDA</a:t>
             </a:r>
           </a:p>
         </p:txBody>
@@ -3244,8 +3227,8 @@
         </p:nvSpPr>
         <p:spPr>
           <a:xfrm>
-            <a:off x="457200" y="274320"/>
-            <a:ext cx="10972800" cy="731520"/>
+            <a:off x="365760" y="182880"/>
+            <a:ext cx="11430000" cy="640080"/>
           </a:xfrm>
           <a:prstGeom prst="rect">
             <a:avLst/>
@@ -3260,7 +3243,7 @@
           <a:p/>
           <a:p>
             <a:pPr>
-              <a:defRPr sz="3200" b="1"/>
+              <a:defRPr sz="3600" b="1"/>
             </a:pPr>
             <a:r>
               <a:t>Data Description</a:t>
@@ -3276,8 +3259,8 @@
         </p:nvSpPr>
         <p:spPr>
           <a:xfrm>
-            <a:off x="457200" y="1188720"/>
-            <a:ext cx="10972800" cy="4572000"/>
+            <a:off x="365760" y="1005840"/>
+            <a:ext cx="11430000" cy="5029200"/>
           </a:xfrm>
           <a:prstGeom prst="rect">
             <a:avLst/>
@@ -3293,45 +3276,34 @@
           <a:p>
             <a:pPr>
               <a:spcAft>
-                <a:spcPts val="800"/>
+                <a:spcPts val="600"/>
               </a:spcAft>
               <a:defRPr sz="1800"/>
             </a:pPr>
             <a:r>
-              <a:t>Two laser powers: 1 nW and 3 nW</a:t>
+              <a:t>Once I had the data, I began analyzing it.</a:t>
             </a:r>
           </a:p>
           <a:p>
             <a:pPr>
               <a:spcAft>
-                <a:spcPts val="800"/>
+                <a:spcPts val="600"/>
               </a:spcAft>
               <a:defRPr sz="1800"/>
             </a:pPr>
             <a:r>
-              <a:t>Transmission values: [5, 10, 20, 40, 60, 80, 100]</a:t>
+              <a:t>I built a single DataFrame with all experiments: 2 lasers (1 nW and 3 nW),</a:t>
             </a:r>
           </a:p>
           <a:p>
             <a:pPr>
               <a:spcAft>
-                <a:spcPts val="800"/>
+                <a:spcPts val="600"/>
               </a:spcAft>
               <a:defRPr sz="1800"/>
             </a:pPr>
             <a:r>
-              <a:t>Each combination has multiple experimental runs</a:t>
-            </a:r>
-          </a:p>
-          <a:p>
-            <a:pPr>
-              <a:spcAft>
-                <a:spcPts val="800"/>
-              </a:spcAft>
-              <a:defRPr sz="1800"/>
-            </a:pPr>
-            <a:r>
-              <a:t>Goal: understand the distribution of FWHM values</a:t>
+              <a:t>each measured across transmissions of [5, 10, 20, 40, 60, 80, 100].</a:t>
             </a:r>
           </a:p>
         </p:txBody>
@@ -3362,8 +3334,8 @@
         </p:nvSpPr>
         <p:spPr>
           <a:xfrm>
-            <a:off x="457200" y="182880"/>
-            <a:ext cx="10972800" cy="548640"/>
+            <a:off x="365760" y="137160"/>
+            <a:ext cx="11430000" cy="640080"/>
           </a:xfrm>
           <a:prstGeom prst="rect">
             <a:avLst/>
@@ -3378,10 +3350,10 @@
           <a:p/>
           <a:p>
             <a:pPr>
-              <a:defRPr sz="2800" b="1"/>
-            </a:pPr>
-            <a:r>
-              <a:t>Experimental Data Overview</a:t>
+              <a:defRPr sz="3600" b="1"/>
+            </a:pPr>
+            <a:r>
+              <a:t>Experimental data overview</a:t>
             </a:r>
           </a:p>
         </p:txBody>
@@ -3402,32 +3374,8 @@
         </p:blipFill>
         <p:spPr>
           <a:xfrm>
-            <a:off x="457200" y="914400"/>
-            <a:ext cx="5029200" cy="2926080"/>
-          </a:xfrm>
-          <a:prstGeom prst="rect">
-            <a:avLst/>
-          </a:prstGeom>
-        </p:spPr>
-      </p:pic>
-      <p:pic>
-        <p:nvPicPr>
-          <p:cNvPr id="4" name="Picture 3" descr="image-6.png"/>
-          <p:cNvPicPr>
-            <a:picLocks noChangeAspect="1"/>
-          </p:cNvPicPr>
-          <p:nvPr/>
-        </p:nvPicPr>
-        <p:blipFill>
-          <a:blip r:embed="rId3"/>
-          <a:stretch>
-            <a:fillRect/>
-          </a:stretch>
-        </p:blipFill>
-        <p:spPr>
-          <a:xfrm>
-            <a:off x="5943600" y="914400"/>
-            <a:ext cx="5029200" cy="2926080"/>
+            <a:off x="365760" y="914400"/>
+            <a:ext cx="10972800" cy="1629624"/>
           </a:xfrm>
           <a:prstGeom prst="rect">
             <a:avLst/>
@@ -3460,8 +3408,8 @@
         </p:nvSpPr>
         <p:spPr>
           <a:xfrm>
-            <a:off x="457200" y="274320"/>
-            <a:ext cx="10972800" cy="548640"/>
+            <a:off x="365760" y="137160"/>
+            <a:ext cx="11430000" cy="640080"/>
           </a:xfrm>
           <a:prstGeom prst="rect">
             <a:avLst/>
@@ -3476,17 +3424,17 @@
           <a:p/>
           <a:p>
             <a:pPr>
-              <a:defRPr sz="2800" b="1"/>
-            </a:pPr>
-            <a:r>
-              <a:t>Success Rate vs Transmission</a:t>
+              <a:defRPr sz="3600" b="1"/>
+            </a:pPr>
+            <a:r>
+              <a:t>Experimental data overview (2)</a:t>
             </a:r>
           </a:p>
         </p:txBody>
       </p:sp>
       <p:pic>
         <p:nvPicPr>
-          <p:cNvPr id="3" name="Picture 2" descr="image-7.png"/>
+          <p:cNvPr id="3" name="Picture 2" descr="image-6.png"/>
           <p:cNvPicPr>
             <a:picLocks noChangeAspect="1"/>
           </p:cNvPicPr>
@@ -3500,8 +3448,8 @@
         </p:blipFill>
         <p:spPr>
           <a:xfrm>
-            <a:off x="914400" y="1097280"/>
-            <a:ext cx="10058400" cy="5029200"/>
+            <a:off x="365760" y="914400"/>
+            <a:ext cx="10972800" cy="3982819"/>
           </a:xfrm>
           <a:prstGeom prst="rect">
             <a:avLst/>
@@ -3534,8 +3482,8 @@
         </p:nvSpPr>
         <p:spPr>
           <a:xfrm>
-            <a:off x="457200" y="274320"/>
-            <a:ext cx="10972800" cy="731520"/>
+            <a:off x="365760" y="137160"/>
+            <a:ext cx="11430000" cy="640080"/>
           </a:xfrm>
           <a:prstGeom prst="rect">
             <a:avLst/>
@@ -3550,71 +3498,38 @@
           <a:p/>
           <a:p>
             <a:pPr>
-              <a:defRPr sz="3200" b="1"/>
-            </a:pPr>
-            <a:r>
-              <a:t>Key Finding</a:t>
-            </a:r>
-          </a:p>
-        </p:txBody>
-      </p:sp>
-      <p:sp>
-        <p:nvSpPr>
-          <p:cNvPr id="3" name="TextBox 2"/>
-          <p:cNvSpPr txBox="1"/>
-          <p:nvPr/>
-        </p:nvSpPr>
-        <p:spPr>
-          <a:xfrm>
-            <a:off x="457200" y="1188720"/>
-            <a:ext cx="10972800" cy="4572000"/>
-          </a:xfrm>
-          <a:prstGeom prst="rect">
-            <a:avLst/>
-          </a:prstGeom>
-          <a:noFill/>
-        </p:spPr>
-        <p:txBody>
-          <a:bodyPr wrap="none">
-            <a:spAutoFit/>
-          </a:bodyPr>
-          <a:lstStyle/>
-          <a:p/>
-          <a:p>
-            <a:pPr>
-              <a:spcAft>
-                <a:spcPts val="800"/>
-              </a:spcAft>
-              <a:defRPr sz="1800"/>
-            </a:pPr>
-            <a:r>
-              <a:t>Higher transmission → fewer NaN values</a:t>
-            </a:r>
-          </a:p>
-          <a:p>
-            <a:pPr>
-              <a:spcAft>
-                <a:spcPts val="800"/>
-              </a:spcAft>
-              <a:defRPr sz="1800"/>
-            </a:pPr>
-            <a:r>
-              <a:t>The more signal, the more reliable the measurement</a:t>
-            </a:r>
-          </a:p>
-          <a:p>
-            <a:pPr>
-              <a:spcAft>
-                <a:spcPts val="800"/>
-              </a:spcAft>
-              <a:defRPr sz="1800"/>
-            </a:pPr>
-            <a:r>
-              <a:t>Clear pattern for both 1 nW and 3 nW laser power</a:t>
-            </a:r>
-          </a:p>
-        </p:txBody>
-      </p:sp>
+              <a:defRPr sz="3600" b="1"/>
+            </a:pPr>
+            <a:r>
+              <a:t>Amount of runs per PLE (with failed fwhm)</a:t>
+            </a:r>
+          </a:p>
+        </p:txBody>
+      </p:sp>
+      <p:pic>
+        <p:nvPicPr>
+          <p:cNvPr id="3" name="Picture 2" descr="image-23.png"/>
+          <p:cNvPicPr>
+            <a:picLocks noChangeAspect="1"/>
+          </p:cNvPicPr>
+          <p:nvPr/>
+        </p:nvPicPr>
+        <p:blipFill>
+          <a:blip r:embed="rId2"/>
+          <a:stretch>
+            <a:fillRect/>
+          </a:stretch>
+        </p:blipFill>
+        <p:spPr>
+          <a:xfrm>
+            <a:off x="365760" y="914400"/>
+            <a:ext cx="10972800" cy="4851567"/>
+          </a:xfrm>
+          <a:prstGeom prst="rect">
+            <a:avLst/>
+          </a:prstGeom>
+        </p:spPr>
+      </p:pic>
     </p:spTree>
   </p:cSld>
   <p:clrMapOvr>
@@ -3641,8 +3556,8 @@
         </p:nvSpPr>
         <p:spPr>
           <a:xfrm>
-            <a:off x="457200" y="274320"/>
-            <a:ext cx="10972800" cy="548640"/>
+            <a:off x="365760" y="137160"/>
+            <a:ext cx="11430000" cy="640080"/>
           </a:xfrm>
           <a:prstGeom prst="rect">
             <a:avLst/>
@@ -3657,17 +3572,52 @@
           <a:p/>
           <a:p>
             <a:pPr>
-              <a:defRPr sz="2800" b="1"/>
-            </a:pPr>
-            <a:r>
-              <a:t>FWHM Distribution — Log Scale</a:t>
+              <a:defRPr sz="3600" b="1"/>
+            </a:pPr>
+            <a:r>
+              <a:t>Success rate vs. transmission</a:t>
+            </a:r>
+          </a:p>
+        </p:txBody>
+      </p:sp>
+      <p:sp>
+        <p:nvSpPr>
+          <p:cNvPr id="3" name="TextBox 2"/>
+          <p:cNvSpPr txBox="1"/>
+          <p:nvPr/>
+        </p:nvSpPr>
+        <p:spPr>
+          <a:xfrm>
+            <a:off x="365760" y="822960"/>
+            <a:ext cx="5486400" cy="5029200"/>
+          </a:xfrm>
+          <a:prstGeom prst="rect">
+            <a:avLst/>
+          </a:prstGeom>
+          <a:noFill/>
+        </p:spPr>
+        <p:txBody>
+          <a:bodyPr wrap="none">
+            <a:spAutoFit/>
+          </a:bodyPr>
+          <a:lstStyle/>
+          <a:p/>
+          <a:p>
+            <a:pPr>
+              <a:spcAft>
+                <a:spcPts val="600"/>
+              </a:spcAft>
+              <a:defRPr sz="1800"/>
+            </a:pPr>
+            <a:r>
+              <a:t>Higher transmission yields fewer NaN values (failed fits) in both cases.</a:t>
             </a:r>
           </a:p>
         </p:txBody>
       </p:sp>
       <p:pic>
         <p:nvPicPr>
-          <p:cNvPr id="3" name="Picture 2" descr="image-9.png"/>
+          <p:cNvPr id="4" name="Picture 3" descr="image-7.png"/>
           <p:cNvPicPr>
             <a:picLocks noChangeAspect="1"/>
           </p:cNvPicPr>
@@ -3681,8 +3631,8 @@
         </p:blipFill>
         <p:spPr>
           <a:xfrm>
-            <a:off x="914400" y="1097280"/>
-            <a:ext cx="10058400" cy="5029200"/>
+            <a:off x="6217920" y="822960"/>
+            <a:ext cx="5486400" cy="3182382"/>
           </a:xfrm>
           <a:prstGeom prst="rect">
             <a:avLst/>
@@ -3715,8 +3665,8 @@
         </p:nvSpPr>
         <p:spPr>
           <a:xfrm>
-            <a:off x="457200" y="274320"/>
-            <a:ext cx="10972800" cy="731520"/>
+            <a:off x="365760" y="182880"/>
+            <a:ext cx="11430000" cy="640080"/>
           </a:xfrm>
           <a:prstGeom prst="rect">
             <a:avLst/>
@@ -3731,67 +3681,10 @@
           <a:p/>
           <a:p>
             <a:pPr>
-              <a:defRPr sz="3200" b="1"/>
-            </a:pPr>
-            <a:r>
-              <a:t>Why Log Scale?</a:t>
-            </a:r>
-          </a:p>
-        </p:txBody>
-      </p:sp>
-      <p:sp>
-        <p:nvSpPr>
-          <p:cNvPr id="3" name="TextBox 2"/>
-          <p:cNvSpPr txBox="1"/>
-          <p:nvPr/>
-        </p:nvSpPr>
-        <p:spPr>
-          <a:xfrm>
-            <a:off x="457200" y="1188720"/>
-            <a:ext cx="10972800" cy="4572000"/>
-          </a:xfrm>
-          <a:prstGeom prst="rect">
-            <a:avLst/>
-          </a:prstGeom>
-          <a:noFill/>
-        </p:spPr>
-        <p:txBody>
-          <a:bodyPr wrap="none">
-            <a:spAutoFit/>
-          </a:bodyPr>
-          <a:lstStyle/>
-          <a:p/>
-          <a:p>
-            <a:pPr>
-              <a:spcAft>
-                <a:spcPts val="800"/>
-              </a:spcAft>
-              <a:defRPr sz="1800"/>
-            </a:pPr>
-            <a:r>
-              <a:t>FWHM values are spread across multiple orders of magnitude</a:t>
-            </a:r>
-          </a:p>
-          <a:p>
-            <a:pPr>
-              <a:spcAft>
-                <a:spcPts val="800"/>
-              </a:spcAft>
-              <a:defRPr sz="1800"/>
-            </a:pPr>
-            <a:r>
-              <a:t>Log scaling reveals structure hidden by extreme values</a:t>
-            </a:r>
-          </a:p>
-          <a:p>
-            <a:pPr>
-              <a:spcAft>
-                <a:spcPts val="800"/>
-              </a:spcAft>
-              <a:defRPr sz="1800"/>
-            </a:pPr>
-            <a:r>
-              <a:t>Makes sense for parameter estimation in log-space</a:t>
+              <a:defRPr sz="3600" b="1"/>
+            </a:pPr>
+            <a:r>
+              <a:t>FWHM distribution per experiment</a:t>
             </a:r>
           </a:p>
         </p:txBody>
@@ -3822,8 +3715,8 @@
         </p:nvSpPr>
         <p:spPr>
           <a:xfrm>
-            <a:off x="457200" y="274320"/>
-            <a:ext cx="10972800" cy="548640"/>
+            <a:off x="365760" y="137160"/>
+            <a:ext cx="11430000" cy="640080"/>
           </a:xfrm>
           <a:prstGeom prst="rect">
             <a:avLst/>
@@ -3838,17 +3731,17 @@
           <a:p/>
           <a:p>
             <a:pPr>
-              <a:defRPr sz="2800" b="1"/>
-            </a:pPr>
-            <a:r>
-              <a:t>FWHM Distributions by Transmission</a:t>
+              <a:defRPr sz="3600" b="1"/>
+            </a:pPr>
+            <a:r>
+              <a:t>Using log scale</a:t>
             </a:r>
           </a:p>
         </p:txBody>
       </p:sp>
       <p:pic>
         <p:nvPicPr>
-          <p:cNvPr id="3" name="Picture 2" descr="image-8.png"/>
+          <p:cNvPr id="3" name="Picture 2" descr="image-9.png"/>
           <p:cNvPicPr>
             <a:picLocks noChangeAspect="1"/>
           </p:cNvPicPr>
@@ -3862,8 +3755,8 @@
         </p:blipFill>
         <p:spPr>
           <a:xfrm>
-            <a:off x="914400" y="1097280"/>
-            <a:ext cx="10058400" cy="5029200"/>
+            <a:off x="365760" y="914400"/>
+            <a:ext cx="10972800" cy="3800978"/>
           </a:xfrm>
           <a:prstGeom prst="rect">
             <a:avLst/>
@@ -3896,8 +3789,8 @@
         </p:nvSpPr>
         <p:spPr>
           <a:xfrm>
-            <a:off x="457200" y="274320"/>
-            <a:ext cx="10972800" cy="731520"/>
+            <a:off x="365760" y="274320"/>
+            <a:ext cx="11430000" cy="5029200"/>
           </a:xfrm>
           <a:prstGeom prst="rect">
             <a:avLst/>
@@ -3912,67 +3805,13 @@
           <a:p/>
           <a:p>
             <a:pPr>
-              <a:defRPr sz="3200" b="1"/>
-            </a:pPr>
-            <a:r>
-              <a:t>Observations</a:t>
-            </a:r>
-          </a:p>
-        </p:txBody>
-      </p:sp>
-      <p:sp>
-        <p:nvSpPr>
-          <p:cNvPr id="3" name="TextBox 2"/>
-          <p:cNvSpPr txBox="1"/>
-          <p:nvPr/>
-        </p:nvSpPr>
-        <p:spPr>
-          <a:xfrm>
-            <a:off x="457200" y="1188720"/>
-            <a:ext cx="10972800" cy="4572000"/>
-          </a:xfrm>
-          <a:prstGeom prst="rect">
-            <a:avLst/>
-          </a:prstGeom>
-          <a:noFill/>
-        </p:spPr>
-        <p:txBody>
-          <a:bodyPr wrap="none">
-            <a:spAutoFit/>
-          </a:bodyPr>
-          <a:lstStyle/>
-          <a:p/>
-          <a:p>
-            <a:pPr>
               <a:spcAft>
-                <a:spcPts val="800"/>
+                <a:spcPts val="600"/>
               </a:spcAft>
               <a:defRPr sz="1800"/>
             </a:pPr>
             <a:r>
-              <a:t>High transmission: clear, well-defined FWHM distribution</a:t>
-            </a:r>
-          </a:p>
-          <a:p>
-            <a:pPr>
-              <a:spcAft>
-                <a:spcPts val="800"/>
-              </a:spcAft>
-              <a:defRPr sz="1800"/>
-            </a:pPr>
-            <a:r>
-              <a:t>Low transmission: wider, noisier distribution</a:t>
-            </a:r>
-          </a:p>
-          <a:p>
-            <a:pPr>
-              <a:spcAft>
-                <a:spcPts val="800"/>
-              </a:spcAft>
-              <a:defRPr sz="1800"/>
-            </a:pPr>
-            <a:r>
-              <a:t>Expected: more signal → better estimates</a:t>
+              <a:t>The FWHM values are widely spread, so log scaling is appropriate.</a:t>
             </a:r>
           </a:p>
         </p:txBody>
@@ -4003,8 +3842,8 @@
         </p:nvSpPr>
         <p:spPr>
           <a:xfrm>
-            <a:off x="457200" y="274320"/>
-            <a:ext cx="10972800" cy="548640"/>
+            <a:off x="365760" y="137160"/>
+            <a:ext cx="11430000" cy="640080"/>
           </a:xfrm>
           <a:prstGeom prst="rect">
             <a:avLst/>
@@ -4019,17 +3858,17 @@
           <a:p/>
           <a:p>
             <a:pPr>
-              <a:defRPr sz="2800" b="1"/>
-            </a:pPr>
-            <a:r>
-              <a:t>FWHM / FWHM Fit Error</a:t>
+              <a:defRPr sz="3600" b="1"/>
+            </a:pPr>
+            <a:r>
+              <a:t>Distributions — High transmission gives clean FWHM</a:t>
             </a:r>
           </a:p>
         </p:txBody>
       </p:sp>
       <p:pic>
         <p:nvPicPr>
-          <p:cNvPr id="3" name="Picture 2" descr="image-10.png"/>
+          <p:cNvPr id="3" name="Picture 2" descr="image-8.png"/>
           <p:cNvPicPr>
             <a:picLocks noChangeAspect="1"/>
           </p:cNvPicPr>
@@ -4043,8 +3882,8 @@
         </p:blipFill>
         <p:spPr>
           <a:xfrm>
-            <a:off x="914400" y="1097280"/>
-            <a:ext cx="10058400" cy="5029200"/>
+            <a:off x="365760" y="914400"/>
+            <a:ext cx="10972800" cy="3800978"/>
           </a:xfrm>
           <a:prstGeom prst="rect">
             <a:avLst/>
@@ -4077,8 +3916,8 @@
         </p:nvSpPr>
         <p:spPr>
           <a:xfrm>
-            <a:off x="457200" y="274320"/>
-            <a:ext cx="10972800" cy="731520"/>
+            <a:off x="365760" y="182880"/>
+            <a:ext cx="11430000" cy="640080"/>
           </a:xfrm>
           <a:prstGeom prst="rect">
             <a:avLst/>
@@ -4093,10 +3932,10 @@
           <a:p/>
           <a:p>
             <a:pPr>
-              <a:defRPr sz="3200" b="1"/>
-            </a:pPr>
-            <a:r>
-              <a:t>Goal</a:t>
+              <a:defRPr sz="3600" b="1"/>
+            </a:pPr>
+            <a:r>
+              <a:t>Toy Examples</a:t>
             </a:r>
           </a:p>
         </p:txBody>
@@ -4109,8 +3948,8 @@
         </p:nvSpPr>
         <p:spPr>
           <a:xfrm>
-            <a:off x="457200" y="1188720"/>
-            <a:ext cx="10972800" cy="4572000"/>
+            <a:off x="365760" y="1005840"/>
+            <a:ext cx="11430000" cy="5029200"/>
           </a:xfrm>
           <a:prstGeom prst="rect">
             <a:avLst/>
@@ -4126,34 +3965,42 @@
           <a:p>
             <a:pPr>
               <a:spcAft>
-                <a:spcPts val="800"/>
+                <a:spcPts val="600"/>
               </a:spcAft>
               <a:defRPr sz="1800"/>
             </a:pPr>
             <a:r>
-              <a:t>Create a differentiable MC simulation for parameter estimation in NV center spectroscopy</a:t>
+              <a:t>Our goal is a differentiable Monte Carlo simulation: a program that takes n and gamma as inputs</a:t>
             </a:r>
           </a:p>
           <a:p>
             <a:pPr>
               <a:spcAft>
-                <a:spcPts val="800"/>
+                <a:spcPts val="600"/>
               </a:spcAft>
               <a:defRPr sz="1800"/>
             </a:pPr>
             <a:r>
-              <a:t>Input: n and gamma → Output: optimizable loss function</a:t>
+              <a:t>and returns a loss function that is optimizable with respect to both.</a:t>
             </a:r>
           </a:p>
           <a:p>
             <a:pPr>
               <a:spcAft>
-                <a:spcPts val="800"/>
+                <a:spcPts val="600"/>
               </a:spcAft>
               <a:defRPr sz="1800"/>
             </a:pPr>
-            <a:r>
-              <a:t>Replace grid search with gradient-based optimization</a:t>
+          </a:p>
+          <a:p>
+            <a:pPr>
+              <a:spcAft>
+                <a:spcPts val="600"/>
+              </a:spcAft>
+              <a:defRPr sz="1800"/>
+            </a:pPr>
+            <a:r>
+              <a:t>To build intuition, I first worked through some toy examples of the optimization idea.</a:t>
             </a:r>
           </a:p>
         </p:txBody>
@@ -4184,8 +4031,8 @@
         </p:nvSpPr>
         <p:spPr>
           <a:xfrm>
-            <a:off x="457200" y="274320"/>
-            <a:ext cx="10972800" cy="731520"/>
+            <a:off x="365760" y="137160"/>
+            <a:ext cx="11430000" cy="640080"/>
           </a:xfrm>
           <a:prstGeom prst="rect">
             <a:avLst/>
@@ -4200,71 +4047,38 @@
           <a:p/>
           <a:p>
             <a:pPr>
-              <a:defRPr sz="3200" b="1"/>
-            </a:pPr>
-            <a:r>
-              <a:t>Error Analysis</a:t>
-            </a:r>
-          </a:p>
-        </p:txBody>
-      </p:sp>
-      <p:sp>
-        <p:nvSpPr>
-          <p:cNvPr id="3" name="TextBox 2"/>
-          <p:cNvSpPr txBox="1"/>
-          <p:nvPr/>
-        </p:nvSpPr>
-        <p:spPr>
-          <a:xfrm>
-            <a:off x="457200" y="1188720"/>
-            <a:ext cx="10972800" cy="4572000"/>
-          </a:xfrm>
-          <a:prstGeom prst="rect">
-            <a:avLst/>
-          </a:prstGeom>
-          <a:noFill/>
-        </p:spPr>
-        <p:txBody>
-          <a:bodyPr wrap="none">
-            <a:spAutoFit/>
-          </a:bodyPr>
-          <a:lstStyle/>
-          <a:p/>
-          <a:p>
-            <a:pPr>
-              <a:spcAft>
-                <a:spcPts val="800"/>
-              </a:spcAft>
-              <a:defRPr sz="1800"/>
-            </a:pPr>
-            <a:r>
-              <a:t>Smaller FWHM → higher relative fit error</a:t>
-            </a:r>
-          </a:p>
-          <a:p>
-            <a:pPr>
-              <a:spcAft>
-                <a:spcPts val="800"/>
-              </a:spcAft>
-              <a:defRPr sz="1800"/>
-            </a:pPr>
-            <a:r>
-              <a:t>Especially problematic for extremely small FWHM values</a:t>
-            </a:r>
-          </a:p>
-          <a:p>
-            <a:pPr>
-              <a:spcAft>
-                <a:spcPts val="800"/>
-              </a:spcAft>
-              <a:defRPr sz="1800"/>
-            </a:pPr>
-            <a:r>
-              <a:t>Important constraint for the optimization</a:t>
-            </a:r>
-          </a:p>
-        </p:txBody>
-      </p:sp>
+              <a:defRPr sz="3600" b="1"/>
+            </a:pPr>
+            <a:r>
+              <a:t>Distributions (2)</a:t>
+            </a:r>
+          </a:p>
+        </p:txBody>
+      </p:sp>
+      <p:pic>
+        <p:nvPicPr>
+          <p:cNvPr id="3" name="Picture 2" descr="image-25.png"/>
+          <p:cNvPicPr>
+            <a:picLocks noChangeAspect="1"/>
+          </p:cNvPicPr>
+          <p:nvPr/>
+        </p:nvPicPr>
+        <p:blipFill>
+          <a:blip r:embed="rId2"/>
+          <a:stretch>
+            <a:fillRect/>
+          </a:stretch>
+        </p:blipFill>
+        <p:spPr>
+          <a:xfrm>
+            <a:off x="365760" y="914400"/>
+            <a:ext cx="10972800" cy="3745564"/>
+          </a:xfrm>
+          <a:prstGeom prst="rect">
+            <a:avLst/>
+          </a:prstGeom>
+        </p:spPr>
+      </p:pic>
     </p:spTree>
   </p:cSld>
   <p:clrMapOvr>
@@ -4291,8 +4105,8 @@
         </p:nvSpPr>
         <p:spPr>
           <a:xfrm>
-            <a:off x="457200" y="274320"/>
-            <a:ext cx="10972800" cy="731520"/>
+            <a:off x="365760" y="137160"/>
+            <a:ext cx="11430000" cy="640080"/>
           </a:xfrm>
           <a:prstGeom prst="rect">
             <a:avLst/>
@@ -4307,10 +4121,10 @@
           <a:p/>
           <a:p>
             <a:pPr>
-              <a:defRPr sz="3200" b="1"/>
-            </a:pPr>
-            <a:r>
-              <a:t>Important Discovery</a:t>
+              <a:defRPr sz="3600" b="1"/>
+            </a:pPr>
+            <a:r>
+              <a:t>FWHM vs. fit error</a:t>
             </a:r>
           </a:p>
         </p:txBody>
@@ -4323,8 +4137,8 @@
         </p:nvSpPr>
         <p:spPr>
           <a:xfrm>
-            <a:off x="457200" y="1188720"/>
-            <a:ext cx="10972800" cy="4572000"/>
+            <a:off x="365760" y="822960"/>
+            <a:ext cx="5486400" cy="5029200"/>
           </a:xfrm>
           <a:prstGeom prst="rect">
             <a:avLst/>
@@ -4340,38 +4154,51 @@
           <a:p>
             <a:pPr>
               <a:spcAft>
-                <a:spcPts val="800"/>
+                <a:spcPts val="600"/>
               </a:spcAft>
               <a:defRPr sz="1800"/>
             </a:pPr>
             <a:r>
-              <a:t>FWHM values are CONTINUOUS, not binned!</a:t>
+              <a:t>The smaller the FWHM, the higher the fit error —</a:t>
             </a:r>
           </a:p>
           <a:p>
             <a:pPr>
               <a:spcAft>
-                <a:spcPts val="800"/>
+                <a:spcPts val="600"/>
               </a:spcAft>
               <a:defRPr sz="1800"/>
             </a:pPr>
             <a:r>
-              <a:t>This simplifies the loss function significantly</a:t>
-            </a:r>
-          </a:p>
-          <a:p>
-            <a:pPr>
-              <a:spcAft>
-                <a:spcPts val="800"/>
-              </a:spcAft>
-              <a:defRPr sz="1800"/>
-            </a:pPr>
-            <a:r>
-              <a:t>We can use continuous divergence measures instead of histogram comparisons</a:t>
-            </a:r>
-          </a:p>
-        </p:txBody>
-      </p:sp>
+              <a:t>this is especially pronounced for the extremely small values.</a:t>
+            </a:r>
+          </a:p>
+        </p:txBody>
+      </p:sp>
+      <p:pic>
+        <p:nvPicPr>
+          <p:cNvPr id="4" name="Picture 3" descr="image-10.png"/>
+          <p:cNvPicPr>
+            <a:picLocks noChangeAspect="1"/>
+          </p:cNvPicPr>
+          <p:nvPr/>
+        </p:nvPicPr>
+        <p:blipFill>
+          <a:blip r:embed="rId2"/>
+          <a:stretch>
+            <a:fillRect/>
+          </a:stretch>
+        </p:blipFill>
+        <p:spPr>
+          <a:xfrm>
+            <a:off x="6217920" y="822960"/>
+            <a:ext cx="5486400" cy="3166513"/>
+          </a:xfrm>
+          <a:prstGeom prst="rect">
+            <a:avLst/>
+          </a:prstGeom>
+        </p:spPr>
+      </p:pic>
     </p:spTree>
   </p:cSld>
   <p:clrMapOvr>
@@ -4398,8 +4225,8 @@
         </p:nvSpPr>
         <p:spPr>
           <a:xfrm>
-            <a:off x="914400" y="2286000"/>
-            <a:ext cx="10058400" cy="1371600"/>
+            <a:off x="365760" y="182880"/>
+            <a:ext cx="11430000" cy="640080"/>
           </a:xfrm>
           <a:prstGeom prst="rect">
             <a:avLst/>
@@ -4413,19 +4240,65 @@
           <a:lstStyle/>
           <a:p/>
           <a:p>
-            <a:pPr algn="ctr">
-              <a:defRPr sz="4000" b="1"/>
-            </a:pPr>
-            <a:r>
-              <a:t>MMD² Loss</a:t>
-            </a:r>
-          </a:p>
-          <a:p>
-            <a:pPr algn="ctr">
-              <a:defRPr sz="2000"/>
-            </a:pPr>
-            <a:r>
-              <a:t>Maximum Mean Discrepancy</a:t>
+            <a:pPr>
+              <a:defRPr sz="3600" b="1"/>
+            </a:pPr>
+            <a:r>
+              <a:t>Good news!</a:t>
+            </a:r>
+          </a:p>
+        </p:txBody>
+      </p:sp>
+      <p:sp>
+        <p:nvSpPr>
+          <p:cNvPr id="3" name="TextBox 2"/>
+          <p:cNvSpPr txBox="1"/>
+          <p:nvPr/>
+        </p:nvSpPr>
+        <p:spPr>
+          <a:xfrm>
+            <a:off x="365760" y="1005840"/>
+            <a:ext cx="11430000" cy="5029200"/>
+          </a:xfrm>
+          <a:prstGeom prst="rect">
+            <a:avLst/>
+          </a:prstGeom>
+          <a:noFill/>
+        </p:spPr>
+        <p:txBody>
+          <a:bodyPr wrap="none">
+            <a:spAutoFit/>
+          </a:bodyPr>
+          <a:lstStyle/>
+          <a:p/>
+          <a:p>
+            <a:pPr>
+              <a:spcAft>
+                <a:spcPts val="600"/>
+              </a:spcAft>
+              <a:defRPr sz="1800"/>
+            </a:pPr>
+            <a:r>
+              <a:t>Key finding: the FWHM are continuous values, not binned as we had assumed.</a:t>
+            </a:r>
+          </a:p>
+          <a:p>
+            <a:pPr>
+              <a:spcAft>
+                <a:spcPts val="600"/>
+              </a:spcAft>
+              <a:defRPr sz="1800"/>
+            </a:pPr>
+          </a:p>
+          <a:p>
+            <a:pPr>
+              <a:spcAft>
+                <a:spcPts val="600"/>
+              </a:spcAft>
+              <a:defRPr sz="1800"/>
+            </a:pPr>
+            <a:r>
+              <a:t>This simplifies the final loss significantly.</a:t>
             </a:r>
           </a:p>
         </p:txBody>
@@ -4456,8 +4329,8 @@
         </p:nvSpPr>
         <p:spPr>
           <a:xfrm>
-            <a:off x="457200" y="274320"/>
-            <a:ext cx="10972800" cy="731520"/>
+            <a:off x="365760" y="182880"/>
+            <a:ext cx="11430000" cy="640080"/>
           </a:xfrm>
           <a:prstGeom prst="rect">
             <a:avLst/>
@@ -4472,78 +4345,10 @@
           <a:p/>
           <a:p>
             <a:pPr>
-              <a:defRPr sz="3200" b="1"/>
-            </a:pPr>
-            <a:r>
-              <a:t>What is MMD²?</a:t>
-            </a:r>
-          </a:p>
-        </p:txBody>
-      </p:sp>
-      <p:sp>
-        <p:nvSpPr>
-          <p:cNvPr id="3" name="TextBox 2"/>
-          <p:cNvSpPr txBox="1"/>
-          <p:nvPr/>
-        </p:nvSpPr>
-        <p:spPr>
-          <a:xfrm>
-            <a:off x="457200" y="1188720"/>
-            <a:ext cx="10972800" cy="4572000"/>
-          </a:xfrm>
-          <a:prstGeom prst="rect">
-            <a:avLst/>
-          </a:prstGeom>
-          <a:noFill/>
-        </p:spPr>
-        <p:txBody>
-          <a:bodyPr wrap="none">
-            <a:spAutoFit/>
-          </a:bodyPr>
-          <a:lstStyle/>
-          <a:p/>
-          <a:p>
-            <a:pPr>
-              <a:spcAft>
-                <a:spcPts val="800"/>
-              </a:spcAft>
-              <a:defRPr sz="1800"/>
-            </a:pPr>
-            <a:r>
-              <a:t>A kernel-based distance between two distributions</a:t>
-            </a:r>
-          </a:p>
-          <a:p>
-            <a:pPr>
-              <a:spcAft>
-                <a:spcPts val="800"/>
-              </a:spcAft>
-              <a:defRPr sz="1800"/>
-            </a:pPr>
-            <a:r>
-              <a:t>Compares two sets of samples without binning</a:t>
-            </a:r>
-          </a:p>
-          <a:p>
-            <a:pPr>
-              <a:spcAft>
-                <a:spcPts val="800"/>
-              </a:spcAft>
-              <a:defRPr sz="1800"/>
-            </a:pPr>
-            <a:r>
-              <a:t>Smooth and differentiable — perfect for gradient-based optimization</a:t>
-            </a:r>
-          </a:p>
-          <a:p>
-            <a:pPr>
-              <a:spcAft>
-                <a:spcPts val="800"/>
-              </a:spcAft>
-              <a:defRPr sz="1800"/>
-            </a:pPr>
-            <a:r>
-              <a:t>Tested on real data: (transmission=60, power=3 nW)</a:t>
+              <a:defRPr sz="3600" b="1"/>
+            </a:pPr>
+            <a:r>
+              <a:t>MMD²</a:t>
             </a:r>
           </a:p>
         </p:txBody>
@@ -4574,8 +4379,8 @@
         </p:nvSpPr>
         <p:spPr>
           <a:xfrm>
-            <a:off x="457200" y="182880"/>
-            <a:ext cx="10972800" cy="548640"/>
+            <a:off x="365760" y="182880"/>
+            <a:ext cx="11430000" cy="640080"/>
           </a:xfrm>
           <a:prstGeom prst="rect">
             <a:avLst/>
@@ -4590,110 +4395,172 @@
           <a:p/>
           <a:p>
             <a:pPr>
-              <a:defRPr sz="2800" b="1"/>
-            </a:pPr>
-            <a:r>
-              <a:t>MMD² Optimization — Step by Step</a:t>
-            </a:r>
-          </a:p>
-        </p:txBody>
-      </p:sp>
-      <p:pic>
-        <p:nvPicPr>
-          <p:cNvPr id="3" name="Picture 2" descr="image-11.png"/>
-          <p:cNvPicPr>
-            <a:picLocks noChangeAspect="1"/>
-          </p:cNvPicPr>
-          <p:nvPr/>
-        </p:nvPicPr>
-        <p:blipFill>
-          <a:blip r:embed="rId2"/>
-          <a:stretch>
-            <a:fillRect/>
-          </a:stretch>
-        </p:blipFill>
-        <p:spPr>
-          <a:xfrm>
-            <a:off x="457200" y="914400"/>
-            <a:ext cx="5029200" cy="2926080"/>
-          </a:xfrm>
-          <a:prstGeom prst="rect">
-            <a:avLst/>
-          </a:prstGeom>
-        </p:spPr>
-      </p:pic>
-      <p:pic>
-        <p:nvPicPr>
-          <p:cNvPr id="4" name="Picture 3" descr="image-12.png"/>
-          <p:cNvPicPr>
-            <a:picLocks noChangeAspect="1"/>
-          </p:cNvPicPr>
-          <p:nvPr/>
-        </p:nvPicPr>
-        <p:blipFill>
-          <a:blip r:embed="rId3"/>
-          <a:stretch>
-            <a:fillRect/>
-          </a:stretch>
-        </p:blipFill>
-        <p:spPr>
-          <a:xfrm>
-            <a:off x="5943600" y="914400"/>
-            <a:ext cx="5029200" cy="2926080"/>
-          </a:xfrm>
-          <a:prstGeom prst="rect">
-            <a:avLst/>
-          </a:prstGeom>
-        </p:spPr>
-      </p:pic>
-      <p:pic>
-        <p:nvPicPr>
-          <p:cNvPr id="5" name="Picture 4" descr="image-13.png"/>
-          <p:cNvPicPr>
-            <a:picLocks noChangeAspect="1"/>
-          </p:cNvPicPr>
-          <p:nvPr/>
-        </p:nvPicPr>
-        <p:blipFill>
-          <a:blip r:embed="rId4"/>
-          <a:stretch>
-            <a:fillRect/>
-          </a:stretch>
-        </p:blipFill>
-        <p:spPr>
-          <a:xfrm>
-            <a:off x="457200" y="3931920"/>
-            <a:ext cx="5029200" cy="2926080"/>
-          </a:xfrm>
-          <a:prstGeom prst="rect">
-            <a:avLst/>
-          </a:prstGeom>
-        </p:spPr>
-      </p:pic>
-      <p:pic>
-        <p:nvPicPr>
-          <p:cNvPr id="6" name="Picture 5" descr="image-14.png"/>
-          <p:cNvPicPr>
-            <a:picLocks noChangeAspect="1"/>
-          </p:cNvPicPr>
-          <p:nvPr/>
-        </p:nvPicPr>
-        <p:blipFill>
-          <a:blip r:embed="rId5"/>
-          <a:stretch>
-            <a:fillRect/>
-          </a:stretch>
-        </p:blipFill>
-        <p:spPr>
-          <a:xfrm>
-            <a:off x="5943600" y="3931920"/>
-            <a:ext cx="5029200" cy="2926080"/>
-          </a:xfrm>
-          <a:prstGeom prst="rect">
-            <a:avLst/>
-          </a:prstGeom>
-        </p:spPr>
-      </p:pic>
+              <a:defRPr sz="3600" b="1"/>
+            </a:pPr>
+            <a:r>
+              <a:t>What is MMD²?</a:t>
+            </a:r>
+          </a:p>
+        </p:txBody>
+      </p:sp>
+      <p:sp>
+        <p:nvSpPr>
+          <p:cNvPr id="3" name="TextBox 2"/>
+          <p:cNvSpPr txBox="1"/>
+          <p:nvPr/>
+        </p:nvSpPr>
+        <p:spPr>
+          <a:xfrm>
+            <a:off x="365760" y="1005840"/>
+            <a:ext cx="11430000" cy="5029200"/>
+          </a:xfrm>
+          <a:prstGeom prst="rect">
+            <a:avLst/>
+          </a:prstGeom>
+          <a:noFill/>
+        </p:spPr>
+        <p:txBody>
+          <a:bodyPr wrap="none">
+            <a:spAutoFit/>
+          </a:bodyPr>
+          <a:lstStyle/>
+          <a:p/>
+          <a:p>
+            <a:pPr>
+              <a:spcAft>
+                <a:spcPts val="600"/>
+              </a:spcAft>
+              <a:defRPr sz="1800"/>
+            </a:pPr>
+            <a:r>
+              <a:t>I found a loss function that compares two lists of samples and tested whether it optimizes on real data,</a:t>
+            </a:r>
+          </a:p>
+          <a:p>
+            <a:pPr>
+              <a:spcAft>
+                <a:spcPts val="600"/>
+              </a:spcAft>
+              <a:defRPr sz="1800"/>
+            </a:pPr>
+            <a:r>
+              <a:t>using (df["transmission"] == 60) &amp; (df["power_nW"] == 3).</a:t>
+            </a:r>
+          </a:p>
+          <a:p>
+            <a:pPr>
+              <a:spcAft>
+                <a:spcPts val="600"/>
+              </a:spcAft>
+              <a:defRPr sz="1800"/>
+            </a:pPr>
+          </a:p>
+          <a:p>
+            <a:pPr>
+              <a:spcAft>
+                <a:spcPts val="600"/>
+              </a:spcAft>
+              <a:defRPr sz="1800"/>
+            </a:pPr>
+            <a:r>
+              <a:t>MMD² (Maximum Mean Discrepancy) measures how different two sets of samples are,</a:t>
+            </a:r>
+          </a:p>
+          <a:p>
+            <a:pPr>
+              <a:spcAft>
+                <a:spcPts val="600"/>
+              </a:spcAft>
+              <a:defRPr sz="1800"/>
+            </a:pPr>
+            <a:r>
+              <a:t>without needing to know their underlying distributions.</a:t>
+            </a:r>
+          </a:p>
+          <a:p>
+            <a:pPr>
+              <a:spcAft>
+                <a:spcPts val="600"/>
+              </a:spcAft>
+              <a:defRPr sz="1800"/>
+            </a:pPr>
+            <a:r>
+              <a:t>It maps the samples into a feature space via a kernel (here a Gaussian/RBF kernel)</a:t>
+            </a:r>
+          </a:p>
+          <a:p>
+            <a:pPr>
+              <a:spcAft>
+                <a:spcPts val="600"/>
+              </a:spcAft>
+              <a:defRPr sz="1800"/>
+            </a:pPr>
+            <a:r>
+              <a:t>and compares their mean embeddings:</a:t>
+            </a:r>
+          </a:p>
+          <a:p>
+            <a:pPr>
+              <a:spcAft>
+                <a:spcPts val="600"/>
+              </a:spcAft>
+              <a:defRPr sz="1800"/>
+            </a:pPr>
+          </a:p>
+          <a:p>
+            <a:pPr>
+              <a:spcAft>
+                <a:spcPts val="600"/>
+              </a:spcAft>
+              <a:defRPr sz="1800"/>
+            </a:pPr>
+            <a:r>
+              <a:t>    MMD²(X, Y) = mean(k(x, x')) + mean(k(y, y')) - 2 * mean(k(x, y))</a:t>
+            </a:r>
+          </a:p>
+          <a:p>
+            <a:pPr>
+              <a:spcAft>
+                <a:spcPts val="600"/>
+              </a:spcAft>
+              <a:defRPr sz="1800"/>
+            </a:pPr>
+          </a:p>
+          <a:p>
+            <a:pPr>
+              <a:spcAft>
+                <a:spcPts val="600"/>
+              </a:spcAft>
+              <a:defRPr sz="1800"/>
+            </a:pPr>
+            <a:r>
+              <a:t>It is 0 when the two sample sets come from the same distribution and grows as they diverge.</a:t>
+            </a:r>
+          </a:p>
+          <a:p>
+            <a:pPr>
+              <a:spcAft>
+                <a:spcPts val="600"/>
+              </a:spcAft>
+              <a:defRPr sz="1800"/>
+            </a:pPr>
+            <a:r>
+              <a:t>Because it is built from a smooth kernel, it is differentiable —</a:t>
+            </a:r>
+          </a:p>
+          <a:p>
+            <a:pPr>
+              <a:spcAft>
+                <a:spcPts val="600"/>
+              </a:spcAft>
+              <a:defRPr sz="1800"/>
+            </a:pPr>
+            <a:r>
+              <a:t>which is exactly what we need to backpropagate through and optimize.</a:t>
+            </a:r>
+          </a:p>
+        </p:txBody>
+      </p:sp>
     </p:spTree>
   </p:cSld>
   <p:clrMapOvr>
@@ -4720,8 +4587,8 @@
         </p:nvSpPr>
         <p:spPr>
           <a:xfrm>
-            <a:off x="457200" y="274320"/>
-            <a:ext cx="10972800" cy="548640"/>
+            <a:off x="365760" y="137160"/>
+            <a:ext cx="11430000" cy="640080"/>
           </a:xfrm>
           <a:prstGeom prst="rect">
             <a:avLst/>
@@ -4736,17 +4603,17 @@
           <a:p/>
           <a:p>
             <a:pPr>
-              <a:defRPr sz="2800" b="1"/>
-            </a:pPr>
-            <a:r>
-              <a:t>MMD² Optimization — Complete</a:t>
+              <a:defRPr sz="3600" b="1"/>
+            </a:pPr>
+            <a:r>
+              <a:t>Development plot for test</a:t>
             </a:r>
           </a:p>
         </p:txBody>
       </p:sp>
       <p:pic>
         <p:nvPicPr>
-          <p:cNvPr id="3" name="Picture 2" descr="image-15.png"/>
+          <p:cNvPr id="3" name="Picture 2" descr="image-11.png"/>
           <p:cNvPicPr>
             <a:picLocks noChangeAspect="1"/>
           </p:cNvPicPr>
@@ -4760,8 +4627,8 @@
         </p:blipFill>
         <p:spPr>
           <a:xfrm>
-            <a:off x="914400" y="1097280"/>
-            <a:ext cx="10058400" cy="5029200"/>
+            <a:off x="365760" y="914400"/>
+            <a:ext cx="10972800" cy="4987636"/>
           </a:xfrm>
           <a:prstGeom prst="rect">
             <a:avLst/>
@@ -4794,8 +4661,8 @@
         </p:nvSpPr>
         <p:spPr>
           <a:xfrm>
-            <a:off x="457200" y="274320"/>
-            <a:ext cx="10972800" cy="548640"/>
+            <a:off x="365760" y="137160"/>
+            <a:ext cx="11430000" cy="640080"/>
           </a:xfrm>
           <a:prstGeom prst="rect">
             <a:avLst/>
@@ -4810,17 +4677,14 @@
           <a:p/>
           <a:p>
             <a:pPr>
-              <a:defRPr sz="2800" b="1"/>
-            </a:pPr>
-            <a:r>
-              <a:t>Sigma Tuning for MMD²</a:t>
-            </a:r>
+              <a:defRPr sz="3600" b="1"/>
+            </a:pPr>
           </a:p>
         </p:txBody>
       </p:sp>
       <p:pic>
         <p:nvPicPr>
-          <p:cNvPr id="3" name="Picture 2" descr="image-16.png"/>
+          <p:cNvPr id="3" name="Picture 2" descr="image-12.png"/>
           <p:cNvPicPr>
             <a:picLocks noChangeAspect="1"/>
           </p:cNvPicPr>
@@ -4834,8 +4698,8 @@
         </p:blipFill>
         <p:spPr>
           <a:xfrm>
-            <a:off x="914400" y="1097280"/>
-            <a:ext cx="10058400" cy="5029200"/>
+            <a:off x="365760" y="914400"/>
+            <a:ext cx="10972800" cy="5400170"/>
           </a:xfrm>
           <a:prstGeom prst="rect">
             <a:avLst/>
@@ -4868,8 +4732,8 @@
         </p:nvSpPr>
         <p:spPr>
           <a:xfrm>
-            <a:off x="457200" y="274320"/>
-            <a:ext cx="10972800" cy="731520"/>
+            <a:off x="365760" y="137160"/>
+            <a:ext cx="11430000" cy="640080"/>
           </a:xfrm>
           <a:prstGeom prst="rect">
             <a:avLst/>
@@ -4884,71 +4748,35 @@
           <a:p/>
           <a:p>
             <a:pPr>
-              <a:defRPr sz="3200" b="1"/>
-            </a:pPr>
-            <a:r>
-              <a:t>Sigma Choice Matters</a:t>
-            </a:r>
-          </a:p>
-        </p:txBody>
-      </p:sp>
-      <p:sp>
-        <p:nvSpPr>
-          <p:cNvPr id="3" name="TextBox 2"/>
-          <p:cNvSpPr txBox="1"/>
-          <p:nvPr/>
-        </p:nvSpPr>
-        <p:spPr>
-          <a:xfrm>
-            <a:off x="457200" y="1188720"/>
-            <a:ext cx="10972800" cy="4572000"/>
-          </a:xfrm>
-          <a:prstGeom prst="rect">
-            <a:avLst/>
-          </a:prstGeom>
-          <a:noFill/>
-        </p:spPr>
-        <p:txBody>
-          <a:bodyPr wrap="none">
-            <a:spAutoFit/>
-          </a:bodyPr>
-          <a:lstStyle/>
-          <a:p/>
-          <a:p>
-            <a:pPr>
-              <a:spcAft>
-                <a:spcPts val="800"/>
-              </a:spcAft>
-              <a:defRPr sz="1800"/>
-            </a:pPr>
-            <a:r>
-              <a:t>The kernel bandwidth sigma affects the optimization landscape</a:t>
-            </a:r>
-          </a:p>
-          <a:p>
-            <a:pPr>
-              <a:spcAft>
-                <a:spcPts val="800"/>
-              </a:spcAft>
-              <a:defRPr sz="1800"/>
-            </a:pPr>
-            <a:r>
-              <a:t>Different sigma values → different results</a:t>
-            </a:r>
-          </a:p>
-          <a:p>
-            <a:pPr>
-              <a:spcAft>
-                <a:spcPts val="800"/>
-              </a:spcAft>
-              <a:defRPr sz="1800"/>
-            </a:pPr>
-            <a:r>
-              <a:t>Needs more experimentation to find the optimal sigma</a:t>
-            </a:r>
-          </a:p>
-        </p:txBody>
-      </p:sp>
+              <a:defRPr sz="3600" b="1"/>
+            </a:pPr>
+          </a:p>
+        </p:txBody>
+      </p:sp>
+      <p:pic>
+        <p:nvPicPr>
+          <p:cNvPr id="3" name="Picture 2" descr="image-13.png"/>
+          <p:cNvPicPr>
+            <a:picLocks noChangeAspect="1"/>
+          </p:cNvPicPr>
+          <p:nvPr/>
+        </p:nvPicPr>
+        <p:blipFill>
+          <a:blip r:embed="rId2"/>
+          <a:stretch>
+            <a:fillRect/>
+          </a:stretch>
+        </p:blipFill>
+        <p:spPr>
+          <a:xfrm>
+            <a:off x="365760" y="914400"/>
+            <a:ext cx="10972800" cy="5127171"/>
+          </a:xfrm>
+          <a:prstGeom prst="rect">
+            <a:avLst/>
+          </a:prstGeom>
+        </p:spPr>
+      </p:pic>
     </p:spTree>
   </p:cSld>
   <p:clrMapOvr>
@@ -4975,8 +4803,8 @@
         </p:nvSpPr>
         <p:spPr>
           <a:xfrm>
-            <a:off x="457200" y="274320"/>
-            <a:ext cx="10972800" cy="731520"/>
+            <a:off x="365760" y="137160"/>
+            <a:ext cx="11430000" cy="640080"/>
           </a:xfrm>
           <a:prstGeom prst="rect">
             <a:avLst/>
@@ -4991,71 +4819,35 @@
           <a:p/>
           <a:p>
             <a:pPr>
-              <a:defRPr sz="3200" b="1"/>
-            </a:pPr>
-            <a:r>
-              <a:t>Conclusion So Far</a:t>
-            </a:r>
-          </a:p>
-        </p:txBody>
-      </p:sp>
-      <p:sp>
-        <p:nvSpPr>
-          <p:cNvPr id="3" name="TextBox 2"/>
-          <p:cNvSpPr txBox="1"/>
-          <p:nvPr/>
-        </p:nvSpPr>
-        <p:spPr>
-          <a:xfrm>
-            <a:off x="457200" y="1188720"/>
-            <a:ext cx="10972800" cy="4572000"/>
-          </a:xfrm>
-          <a:prstGeom prst="rect">
-            <a:avLst/>
-          </a:prstGeom>
-          <a:noFill/>
-        </p:spPr>
-        <p:txBody>
-          <a:bodyPr wrap="none">
-            <a:spAutoFit/>
-          </a:bodyPr>
-          <a:lstStyle/>
-          <a:p/>
-          <a:p>
-            <a:pPr>
-              <a:spcAft>
-                <a:spcPts val="800"/>
-              </a:spcAft>
-              <a:defRPr sz="1800"/>
-            </a:pPr>
-            <a:r>
-              <a:t>d(Loss)/d(FWHM) is computable — gradient flows through MMD²</a:t>
-            </a:r>
-          </a:p>
-          <a:p>
-            <a:pPr>
-              <a:spcAft>
-                <a:spcPts val="800"/>
-              </a:spcAft>
-              <a:defRPr sz="1800"/>
-            </a:pPr>
-            <a:r>
-              <a:t>Next step: compute d(FWHM)/d(frequencies)</a:t>
-            </a:r>
-          </a:p>
-          <a:p>
-            <a:pPr>
-              <a:spcAft>
-                <a:spcPts val="800"/>
-              </a:spcAft>
-              <a:defRPr sz="1800"/>
-            </a:pPr>
-            <a:r>
-              <a:t>Chain rule: dLoss/d(params) = dLoss/dFWHM × dFWHM/d(freqs)</a:t>
-            </a:r>
-          </a:p>
-        </p:txBody>
-      </p:sp>
+              <a:defRPr sz="3600" b="1"/>
+            </a:pPr>
+          </a:p>
+        </p:txBody>
+      </p:sp>
+      <p:pic>
+        <p:nvPicPr>
+          <p:cNvPr id="3" name="Picture 2" descr="image-14.png"/>
+          <p:cNvPicPr>
+            <a:picLocks noChangeAspect="1"/>
+          </p:cNvPicPr>
+          <p:nvPr/>
+        </p:nvPicPr>
+        <p:blipFill>
+          <a:blip r:embed="rId2"/>
+          <a:stretch>
+            <a:fillRect/>
+          </a:stretch>
+        </p:blipFill>
+        <p:spPr>
+          <a:xfrm>
+            <a:off x="365760" y="914400"/>
+            <a:ext cx="10972800" cy="5127171"/>
+          </a:xfrm>
+          <a:prstGeom prst="rect">
+            <a:avLst/>
+          </a:prstGeom>
+        </p:spPr>
+      </p:pic>
     </p:spTree>
   </p:cSld>
   <p:clrMapOvr>
@@ -5082,8 +4874,8 @@
         </p:nvSpPr>
         <p:spPr>
           <a:xfrm>
-            <a:off x="914400" y="2286000"/>
-            <a:ext cx="10058400" cy="1371600"/>
+            <a:off x="365760" y="137160"/>
+            <a:ext cx="11430000" cy="640080"/>
           </a:xfrm>
           <a:prstGeom prst="rect">
             <a:avLst/>
@@ -5097,23 +4889,36 @@
           <a:lstStyle/>
           <a:p/>
           <a:p>
-            <a:pPr algn="ctr">
-              <a:defRPr sz="4000" b="1"/>
-            </a:pPr>
-            <a:r>
-              <a:t>Gamma Optimization</a:t>
-            </a:r>
-          </a:p>
-          <a:p>
-            <a:pPr algn="ctr">
-              <a:defRPr sz="2000"/>
-            </a:pPr>
-            <a:r>
-              <a:t>End-to-end test</a:t>
-            </a:r>
-          </a:p>
-        </p:txBody>
-      </p:sp>
+            <a:pPr>
+              <a:defRPr sz="3600" b="1"/>
+            </a:pPr>
+          </a:p>
+        </p:txBody>
+      </p:sp>
+      <p:pic>
+        <p:nvPicPr>
+          <p:cNvPr id="3" name="Picture 2" descr="image-15.png"/>
+          <p:cNvPicPr>
+            <a:picLocks noChangeAspect="1"/>
+          </p:cNvPicPr>
+          <p:nvPr/>
+        </p:nvPicPr>
+        <p:blipFill>
+          <a:blip r:embed="rId2"/>
+          <a:stretch>
+            <a:fillRect/>
+          </a:stretch>
+        </p:blipFill>
+        <p:spPr>
+          <a:xfrm>
+            <a:off x="365760" y="914400"/>
+            <a:ext cx="10972800" cy="5127171"/>
+          </a:xfrm>
+          <a:prstGeom prst="rect">
+            <a:avLst/>
+          </a:prstGeom>
+        </p:spPr>
+      </p:pic>
     </p:spTree>
   </p:cSld>
   <p:clrMapOvr>
@@ -5140,8 +4945,8 @@
         </p:nvSpPr>
         <p:spPr>
           <a:xfrm>
-            <a:off x="914400" y="2286000"/>
-            <a:ext cx="10058400" cy="1371600"/>
+            <a:off x="365760" y="137160"/>
+            <a:ext cx="11430000" cy="640080"/>
           </a:xfrm>
           <a:prstGeom prst="rect">
             <a:avLst/>
@@ -5155,23 +4960,170 @@
           <a:lstStyle/>
           <a:p/>
           <a:p>
-            <a:pPr algn="ctr">
-              <a:defRPr sz="4000" b="1"/>
-            </a:pPr>
-            <a:r>
-              <a:t>Toy Examples</a:t>
-            </a:r>
-          </a:p>
-          <a:p>
-            <a:pPr algn="ctr">
-              <a:defRPr sz="2000"/>
-            </a:pPr>
-            <a:r>
-              <a:t>Building intuition step by step</a:t>
-            </a:r>
-          </a:p>
-        </p:txBody>
-      </p:sp>
+            <a:pPr>
+              <a:defRPr sz="3600" b="1"/>
+            </a:pPr>
+            <a:r>
+              <a:t>For n</a:t>
+            </a:r>
+          </a:p>
+        </p:txBody>
+      </p:sp>
+      <p:sp>
+        <p:nvSpPr>
+          <p:cNvPr id="3" name="TextBox 2"/>
+          <p:cNvSpPr txBox="1"/>
+          <p:nvPr/>
+        </p:nvSpPr>
+        <p:spPr>
+          <a:xfrm>
+            <a:off x="365760" y="822960"/>
+            <a:ext cx="5486400" cy="5029200"/>
+          </a:xfrm>
+          <a:prstGeom prst="rect">
+            <a:avLst/>
+          </a:prstGeom>
+          <a:noFill/>
+        </p:spPr>
+        <p:txBody>
+          <a:bodyPr wrap="none">
+            <a:spAutoFit/>
+          </a:bodyPr>
+          <a:lstStyle/>
+          <a:p/>
+          <a:p>
+            <a:pPr>
+              <a:spcAft>
+                <a:spcPts val="600"/>
+              </a:spcAft>
+              <a:defRPr sz="1800"/>
+            </a:pPr>
+            <a:r>
+              <a:t>I created a simple program that samples n from a N(n, sigma) distribution,</a:t>
+            </a:r>
+          </a:p>
+          <a:p>
+            <a:pPr>
+              <a:spcAft>
+                <a:spcPts val="600"/>
+              </a:spcAft>
+              <a:defRPr sz="1800"/>
+            </a:pPr>
+            <a:r>
+              <a:t>uses that sample to run a for loop that adds +1 to a prediction at each iteration,</a:t>
+            </a:r>
+          </a:p>
+          <a:p>
+            <a:pPr>
+              <a:spcAft>
+                <a:spcPts val="600"/>
+              </a:spcAft>
+              <a:defRPr sz="1800"/>
+            </a:pPr>
+            <a:r>
+              <a:t>and then compares the prediction against a target.</a:t>
+            </a:r>
+          </a:p>
+          <a:p>
+            <a:pPr>
+              <a:spcAft>
+                <a:spcPts val="600"/>
+              </a:spcAft>
+              <a:defRPr sz="1800"/>
+            </a:pPr>
+          </a:p>
+          <a:p>
+            <a:pPr>
+              <a:spcAft>
+                <a:spcPts val="600"/>
+              </a:spcAft>
+              <a:defRPr sz="1800"/>
+            </a:pPr>
+            <a:r>
+              <a:t>    sample = normal(mean=n, std=sigma)</a:t>
+            </a:r>
+          </a:p>
+          <a:p>
+            <a:pPr>
+              <a:spcAft>
+                <a:spcPts val="600"/>
+              </a:spcAft>
+              <a:defRPr sz="1800"/>
+            </a:pPr>
+            <a:r>
+              <a:t>    pred = 0</a:t>
+            </a:r>
+          </a:p>
+          <a:p>
+            <a:pPr>
+              <a:spcAft>
+                <a:spcPts val="600"/>
+              </a:spcAft>
+              <a:defRPr sz="1800"/>
+            </a:pPr>
+            <a:r>
+              <a:t>    for i in range(round(sample)):</a:t>
+            </a:r>
+          </a:p>
+          <a:p>
+            <a:pPr>
+              <a:spcAft>
+                <a:spcPts val="600"/>
+              </a:spcAft>
+              <a:defRPr sz="1800"/>
+            </a:pPr>
+            <a:r>
+              <a:t>        pred = pred + 1</a:t>
+            </a:r>
+          </a:p>
+          <a:p>
+            <a:pPr>
+              <a:spcAft>
+                <a:spcPts val="600"/>
+              </a:spcAft>
+              <a:defRPr sz="1800"/>
+            </a:pPr>
+            <a:r>
+              <a:t>    loss = (pred - target)^2</a:t>
+            </a:r>
+          </a:p>
+          <a:p>
+            <a:pPr>
+              <a:spcAft>
+                <a:spcPts val="600"/>
+              </a:spcAft>
+              <a:defRPr sz="1800"/>
+            </a:pPr>
+            <a:r>
+              <a:t>    # backprop loss -&gt; optimize n</a:t>
+            </a:r>
+          </a:p>
+        </p:txBody>
+      </p:sp>
+      <p:pic>
+        <p:nvPicPr>
+          <p:cNvPr id="4" name="Picture 3" descr="image.png"/>
+          <p:cNvPicPr>
+            <a:picLocks noChangeAspect="1"/>
+          </p:cNvPicPr>
+          <p:nvPr/>
+        </p:nvPicPr>
+        <p:blipFill>
+          <a:blip r:embed="rId2"/>
+          <a:stretch>
+            <a:fillRect/>
+          </a:stretch>
+        </p:blipFill>
+        <p:spPr>
+          <a:xfrm>
+            <a:off x="6217920" y="822960"/>
+            <a:ext cx="5486400" cy="1792160"/>
+          </a:xfrm>
+          <a:prstGeom prst="rect">
+            <a:avLst/>
+          </a:prstGeom>
+        </p:spPr>
+      </p:pic>
     </p:spTree>
   </p:cSld>
   <p:clrMapOvr>
@@ -5198,8 +5150,8 @@
         </p:nvSpPr>
         <p:spPr>
           <a:xfrm>
-            <a:off x="457200" y="274320"/>
-            <a:ext cx="10972800" cy="731520"/>
+            <a:off x="365760" y="137160"/>
+            <a:ext cx="11430000" cy="640080"/>
           </a:xfrm>
           <a:prstGeom prst="rect">
             <a:avLst/>
@@ -5214,10 +5166,10 @@
           <a:p/>
           <a:p>
             <a:pPr>
-              <a:defRPr sz="3200" b="1"/>
-            </a:pPr>
-            <a:r>
-              <a:t>Gamma Differentiable Pipeline</a:t>
+              <a:defRPr sz="3600" b="1"/>
+            </a:pPr>
+            <a:r>
+              <a:t>Sigma tuning</a:t>
             </a:r>
           </a:p>
         </p:txBody>
@@ -5230,8 +5182,8 @@
         </p:nvSpPr>
         <p:spPr>
           <a:xfrm>
-            <a:off x="457200" y="1188720"/>
-            <a:ext cx="10972800" cy="4572000"/>
+            <a:off x="365760" y="822960"/>
+            <a:ext cx="5486400" cy="5029200"/>
           </a:xfrm>
           <a:prstGeom prst="rect">
             <a:avLst/>
@@ -5247,38 +5199,51 @@
           <a:p>
             <a:pPr>
               <a:spcAft>
-                <a:spcPts val="800"/>
+                <a:spcPts val="600"/>
               </a:spcAft>
               <a:defRPr sz="1800"/>
             </a:pPr>
             <a:r>
-              <a:t>Created synthetic data with a known gamma</a:t>
+              <a:t>The choice of sigma in the loss affects the result.</a:t>
             </a:r>
           </a:p>
           <a:p>
             <a:pPr>
               <a:spcAft>
-                <a:spcPts val="800"/>
+                <a:spcPts val="600"/>
               </a:spcAft>
               <a:defRPr sz="1800"/>
             </a:pPr>
             <a:r>
-              <a:t>Applied MMD² loss between synthetic and target</a:t>
-            </a:r>
-          </a:p>
-          <a:p>
-            <a:pPr>
-              <a:spcAft>
-                <a:spcPts val="800"/>
-              </a:spcAft>
-              <a:defRPr sz="1800"/>
-            </a:pPr>
-            <a:r>
-              <a:t>Tested: can the gradient reach gamma?</a:t>
-            </a:r>
-          </a:p>
-        </p:txBody>
-      </p:sp>
+              <a:t>This warrants further experimentation.</a:t>
+            </a:r>
+          </a:p>
+        </p:txBody>
+      </p:sp>
+      <p:pic>
+        <p:nvPicPr>
+          <p:cNvPr id="4" name="Picture 3" descr="image-16.png"/>
+          <p:cNvPicPr>
+            <a:picLocks noChangeAspect="1"/>
+          </p:cNvPicPr>
+          <p:nvPr/>
+        </p:nvPicPr>
+        <p:blipFill>
+          <a:blip r:embed="rId2"/>
+          <a:stretch>
+            <a:fillRect/>
+          </a:stretch>
+        </p:blipFill>
+        <p:spPr>
+          <a:xfrm>
+            <a:off x="6217920" y="822960"/>
+            <a:ext cx="5486400" cy="2722436"/>
+          </a:xfrm>
+          <a:prstGeom prst="rect">
+            <a:avLst/>
+          </a:prstGeom>
+        </p:spPr>
+      </p:pic>
     </p:spTree>
   </p:cSld>
   <p:clrMapOvr>
@@ -5305,8 +5270,8 @@
         </p:nvSpPr>
         <p:spPr>
           <a:xfrm>
-            <a:off x="457200" y="274320"/>
-            <a:ext cx="10972800" cy="548640"/>
+            <a:off x="365760" y="182880"/>
+            <a:ext cx="11430000" cy="640080"/>
           </a:xfrm>
           <a:prstGeom prst="rect">
             <a:avLst/>
@@ -5321,38 +5286,68 @@
           <a:p/>
           <a:p>
             <a:pPr>
-              <a:defRPr sz="2800" b="1"/>
-            </a:pPr>
-            <a:r>
-              <a:t>Gamma Optimization — Results</a:t>
-            </a:r>
-          </a:p>
-        </p:txBody>
-      </p:sp>
-      <p:pic>
-        <p:nvPicPr>
-          <p:cNvPr id="3" name="Picture 2" descr="image-17.png"/>
-          <p:cNvPicPr>
-            <a:picLocks noChangeAspect="1"/>
-          </p:cNvPicPr>
-          <p:nvPr/>
-        </p:nvPicPr>
-        <p:blipFill>
-          <a:blip r:embed="rId2"/>
-          <a:stretch>
-            <a:fillRect/>
-          </a:stretch>
-        </p:blipFill>
-        <p:spPr>
-          <a:xfrm>
-            <a:off x="914400" y="1097280"/>
-            <a:ext cx="10058400" cy="5029200"/>
-          </a:xfrm>
-          <a:prstGeom prst="rect">
-            <a:avLst/>
-          </a:prstGeom>
-        </p:spPr>
-      </p:pic>
+              <a:defRPr sz="3600" b="1"/>
+            </a:pPr>
+            <a:r>
+              <a:t>Conclusion</a:t>
+            </a:r>
+          </a:p>
+        </p:txBody>
+      </p:sp>
+      <p:sp>
+        <p:nvSpPr>
+          <p:cNvPr id="3" name="TextBox 2"/>
+          <p:cNvSpPr txBox="1"/>
+          <p:nvPr/>
+        </p:nvSpPr>
+        <p:spPr>
+          <a:xfrm>
+            <a:off x="365760" y="1005840"/>
+            <a:ext cx="11430000" cy="5029200"/>
+          </a:xfrm>
+          <a:prstGeom prst="rect">
+            <a:avLst/>
+          </a:prstGeom>
+          <a:noFill/>
+        </p:spPr>
+        <p:txBody>
+          <a:bodyPr wrap="none">
+            <a:spAutoFit/>
+          </a:bodyPr>
+          <a:lstStyle/>
+          <a:p/>
+          <a:p>
+            <a:pPr>
+              <a:spcAft>
+                <a:spcPts val="600"/>
+              </a:spcAft>
+              <a:defRPr sz="1800"/>
+            </a:pPr>
+            <a:r>
+              <a:t>It works: dLoss/dFWHM is computed.</a:t>
+            </a:r>
+          </a:p>
+          <a:p>
+            <a:pPr>
+              <a:spcAft>
+                <a:spcPts val="600"/>
+              </a:spcAft>
+              <a:defRPr sz="1800"/>
+            </a:pPr>
+          </a:p>
+          <a:p>
+            <a:pPr>
+              <a:spcAft>
+                <a:spcPts val="600"/>
+              </a:spcAft>
+              <a:defRPr sz="1800"/>
+            </a:pPr>
+            <a:r>
+              <a:t>The next step is dFWHM / dfrequencies.</a:t>
+            </a:r>
+          </a:p>
+        </p:txBody>
+      </p:sp>
     </p:spTree>
   </p:cSld>
   <p:clrMapOvr>
@@ -5379,8 +5374,8 @@
         </p:nvSpPr>
         <p:spPr>
           <a:xfrm>
-            <a:off x="914400" y="2286000"/>
-            <a:ext cx="10058400" cy="1371600"/>
+            <a:off x="365760" y="137160"/>
+            <a:ext cx="11430000" cy="640080"/>
           </a:xfrm>
           <a:prstGeom prst="rect">
             <a:avLst/>
@@ -5394,43 +5389,25 @@
           <a:lstStyle/>
           <a:p/>
           <a:p>
-            <a:pPr algn="ctr">
-              <a:defRPr sz="4000" b="1"/>
-            </a:pPr>
-            <a:r>
-              <a:t>Next Steps</a:t>
-            </a:r>
-          </a:p>
-        </p:txBody>
-      </p:sp>
-    </p:spTree>
-  </p:cSld>
-  <p:clrMapOvr>
-    <a:masterClrMapping/>
-  </p:clrMapOvr>
-</p:sld>
-</file>
-
-<file path=ppt/slides/slide33.xml><?xml version="1.0" encoding="utf-8"?>
-<p:sld xmlns:a="http://schemas.openxmlformats.org/drawingml/2006/main" xmlns:p="http://schemas.openxmlformats.org/presentationml/2006/main" xmlns:r="http://schemas.openxmlformats.org/officeDocument/2006/relationships">
-  <p:cSld>
-    <p:spTree>
-      <p:nvGrpSpPr>
-        <p:cNvPr id="1" name=""/>
-        <p:cNvGrpSpPr/>
-        <p:nvPr/>
-      </p:nvGrpSpPr>
-      <p:grpSpPr/>
-      <p:sp>
-        <p:nvSpPr>
-          <p:cNvPr id="2" name="TextBox 1"/>
+            <a:pPr>
+              <a:defRPr sz="3600" b="1"/>
+            </a:pPr>
+            <a:r>
+              <a:t>Gamma differentiable</a:t>
+            </a:r>
+          </a:p>
+        </p:txBody>
+      </p:sp>
+      <p:sp>
+        <p:nvSpPr>
+          <p:cNvPr id="3" name="TextBox 2"/>
           <p:cNvSpPr txBox="1"/>
           <p:nvPr/>
         </p:nvSpPr>
         <p:spPr>
           <a:xfrm>
-            <a:off x="457200" y="274320"/>
-            <a:ext cx="10972800" cy="731520"/>
+            <a:off x="365760" y="822960"/>
+            <a:ext cx="5486400" cy="5029200"/>
           </a:xfrm>
           <a:prstGeom prst="rect">
             <a:avLst/>
@@ -5445,93 +5422,52 @@
           <a:p/>
           <a:p>
             <a:pPr>
-              <a:defRPr sz="3200" b="1"/>
-            </a:pPr>
-            <a:r>
-              <a:t>Next Steps</a:t>
-            </a:r>
-          </a:p>
-        </p:txBody>
-      </p:sp>
-      <p:sp>
-        <p:nvSpPr>
-          <p:cNvPr id="3" name="TextBox 2"/>
-          <p:cNvSpPr txBox="1"/>
-          <p:nvPr/>
-        </p:nvSpPr>
-        <p:spPr>
-          <a:xfrm>
-            <a:off x="457200" y="1188720"/>
-            <a:ext cx="10972800" cy="4572000"/>
-          </a:xfrm>
-          <a:prstGeom prst="rect">
-            <a:avLst/>
-          </a:prstGeom>
-          <a:noFill/>
-        </p:spPr>
-        <p:txBody>
-          <a:bodyPr wrap="none">
-            <a:spAutoFit/>
-          </a:bodyPr>
-          <a:lstStyle/>
-          <a:p/>
-          <a:p>
-            <a:pPr>
               <a:spcAft>
-                <a:spcPts val="800"/>
+                <a:spcPts val="600"/>
               </a:spcAft>
               <a:defRPr sz="1800"/>
             </a:pPr>
             <a:r>
-              <a:t>1. Connect all pieces: sampling → fitting → loss → gradient</a:t>
+              <a:t>We test it by creating a true gamma distribution</a:t>
             </a:r>
           </a:p>
           <a:p>
             <a:pPr>
               <a:spcAft>
-                <a:spcPts val="800"/>
+                <a:spcPts val="600"/>
               </a:spcAft>
               <a:defRPr sz="1800"/>
             </a:pPr>
             <a:r>
-              <a:t>2. Test on real experimental data</a:t>
-            </a:r>
-          </a:p>
-          <a:p>
-            <a:pPr>
-              <a:spcAft>
-                <a:spcPts val="800"/>
-              </a:spcAft>
-              <a:defRPr sz="1800"/>
-            </a:pPr>
-            <a:r>
-              <a:t>3. Optimize sigma kernel parameter</a:t>
-            </a:r>
-          </a:p>
-          <a:p>
-            <a:pPr>
-              <a:spcAft>
-                <a:spcPts val="800"/>
-              </a:spcAft>
-              <a:defRPr sz="1800"/>
-            </a:pPr>
-            <a:r>
-              <a:t>4. Explore d(FWHM)/d(frequencies) chain</a:t>
-            </a:r>
-          </a:p>
-          <a:p>
-            <a:pPr>
-              <a:spcAft>
-                <a:spcPts val="800"/>
-              </a:spcAft>
-              <a:defRPr sz="1800"/>
-            </a:pPr>
-            <a:r>
-              <a:t>5. Compare with grid search results from the paper</a:t>
-            </a:r>
-          </a:p>
-        </p:txBody>
-      </p:sp>
+              <a:t>and building the MMD² loss from it.</a:t>
+            </a:r>
+          </a:p>
+        </p:txBody>
+      </p:sp>
+      <p:pic>
+        <p:nvPicPr>
+          <p:cNvPr id="4" name="Picture 3" descr="image-17.png"/>
+          <p:cNvPicPr>
+            <a:picLocks noChangeAspect="1"/>
+          </p:cNvPicPr>
+          <p:nvPr/>
+        </p:nvPicPr>
+        <p:blipFill>
+          <a:blip r:embed="rId2"/>
+          <a:stretch>
+            <a:fillRect/>
+          </a:stretch>
+        </p:blipFill>
+        <p:spPr>
+          <a:xfrm>
+            <a:off x="6217920" y="822960"/>
+            <a:ext cx="5486400" cy="1799576"/>
+          </a:xfrm>
+          <a:prstGeom prst="rect">
+            <a:avLst/>
+          </a:prstGeom>
+        </p:spPr>
+      </p:pic>
     </p:spTree>
   </p:cSld>
   <p:clrMapOvr>
@@ -5558,8 +5494,8 @@
         </p:nvSpPr>
         <p:spPr>
           <a:xfrm>
-            <a:off x="457200" y="274320"/>
-            <a:ext cx="10972800" cy="731520"/>
+            <a:off x="365760" y="137160"/>
+            <a:ext cx="11430000" cy="640080"/>
           </a:xfrm>
           <a:prstGeom prst="rect">
             <a:avLst/>
@@ -5574,82 +5510,38 @@
           <a:p/>
           <a:p>
             <a:pPr>
-              <a:defRPr sz="3200" b="1"/>
-            </a:pPr>
-            <a:r>
-              <a:t>Toy Example — Optimizing n</a:t>
-            </a:r>
-          </a:p>
-        </p:txBody>
-      </p:sp>
-      <p:sp>
-        <p:nvSpPr>
-          <p:cNvPr id="3" name="TextBox 2"/>
-          <p:cNvSpPr txBox="1"/>
-          <p:nvPr/>
-        </p:nvSpPr>
-        <p:spPr>
-          <a:xfrm>
-            <a:off x="457200" y="1188720"/>
-            <a:ext cx="10972800" cy="4572000"/>
-          </a:xfrm>
-          <a:prstGeom prst="rect">
-            <a:avLst/>
-          </a:prstGeom>
-          <a:noFill/>
-        </p:spPr>
-        <p:txBody>
-          <a:bodyPr wrap="none">
-            <a:spAutoFit/>
-          </a:bodyPr>
-          <a:lstStyle/>
-          <a:p/>
-          <a:p>
-            <a:pPr>
-              <a:spcAft>
-                <a:spcPts val="800"/>
-              </a:spcAft>
-              <a:defRPr sz="1800"/>
-            </a:pPr>
-            <a:r>
-              <a:t>n sampled from N(n, sigma)</a:t>
-            </a:r>
-          </a:p>
-          <a:p>
-            <a:pPr>
-              <a:spcAft>
-                <a:spcPts val="800"/>
-              </a:spcAft>
-              <a:defRPr sz="1800"/>
-            </a:pPr>
-            <a:r>
-              <a:t>For loop adds +1 per iteration (simulating run count)</a:t>
-            </a:r>
-          </a:p>
-          <a:p>
-            <a:pPr>
-              <a:spcAft>
-                <a:spcPts val="800"/>
-              </a:spcAft>
-              <a:defRPr sz="1800"/>
-            </a:pPr>
-            <a:r>
-              <a:t>Loss: compare prediction to a target</a:t>
-            </a:r>
-          </a:p>
-          <a:p>
-            <a:pPr>
-              <a:spcAft>
-                <a:spcPts val="800"/>
-              </a:spcAft>
-              <a:defRPr sz="1800"/>
-            </a:pPr>
-            <a:r>
-              <a:t>Gradient flows through the sampling step</a:t>
-            </a:r>
-          </a:p>
-        </p:txBody>
-      </p:sp>
+              <a:defRPr sz="3600" b="1"/>
+            </a:pPr>
+            <a:r>
+              <a:t>For n — Results</a:t>
+            </a:r>
+          </a:p>
+        </p:txBody>
+      </p:sp>
+      <p:pic>
+        <p:nvPicPr>
+          <p:cNvPr id="3" name="Picture 2" descr="image-2.png"/>
+          <p:cNvPicPr>
+            <a:picLocks noChangeAspect="1"/>
+          </p:cNvPicPr>
+          <p:nvPr/>
+        </p:nvPicPr>
+        <p:blipFill>
+          <a:blip r:embed="rId2"/>
+          <a:stretch>
+            <a:fillRect/>
+          </a:stretch>
+        </p:blipFill>
+        <p:spPr>
+          <a:xfrm>
+            <a:off x="365760" y="914400"/>
+            <a:ext cx="10972800" cy="3332794"/>
+          </a:xfrm>
+          <a:prstGeom prst="rect">
+            <a:avLst/>
+          </a:prstGeom>
+        </p:spPr>
+      </p:pic>
     </p:spTree>
   </p:cSld>
   <p:clrMapOvr>
@@ -5676,8 +5568,8 @@
         </p:nvSpPr>
         <p:spPr>
           <a:xfrm>
-            <a:off x="457200" y="274320"/>
-            <a:ext cx="10972800" cy="548640"/>
+            <a:off x="365760" y="137160"/>
+            <a:ext cx="11430000" cy="640080"/>
           </a:xfrm>
           <a:prstGeom prst="rect">
             <a:avLst/>
@@ -5692,17 +5584,17 @@
           <a:p/>
           <a:p>
             <a:pPr>
-              <a:defRPr sz="2800" b="1"/>
-            </a:pPr>
-            <a:r>
-              <a:t>n Optimization — Results</a:t>
+              <a:defRPr sz="3600" b="1"/>
+            </a:pPr>
+            <a:r>
+              <a:t>For sigma</a:t>
             </a:r>
           </a:p>
         </p:txBody>
       </p:sp>
       <p:pic>
         <p:nvPicPr>
-          <p:cNvPr id="3" name="Picture 2" descr="image.png"/>
+          <p:cNvPr id="3" name="Picture 2" descr="image-18.png"/>
           <p:cNvPicPr>
             <a:picLocks noChangeAspect="1"/>
           </p:cNvPicPr>
@@ -5716,8 +5608,8 @@
         </p:blipFill>
         <p:spPr>
           <a:xfrm>
-            <a:off x="914400" y="1097280"/>
-            <a:ext cx="10058400" cy="5029200"/>
+            <a:off x="365760" y="914400"/>
+            <a:ext cx="10972800" cy="1898735"/>
           </a:xfrm>
           <a:prstGeom prst="rect">
             <a:avLst/>
@@ -5750,8 +5642,8 @@
         </p:nvSpPr>
         <p:spPr>
           <a:xfrm>
-            <a:off x="457200" y="274320"/>
-            <a:ext cx="10972800" cy="548640"/>
+            <a:off x="365760" y="137160"/>
+            <a:ext cx="11430000" cy="640080"/>
           </a:xfrm>
           <a:prstGeom prst="rect">
             <a:avLst/>
@@ -5766,17 +5658,17 @@
           <a:p/>
           <a:p>
             <a:pPr>
-              <a:defRPr sz="2800" b="1"/>
-            </a:pPr>
-            <a:r>
-              <a:t>n Optimization — Convergence</a:t>
+              <a:defRPr sz="3600" b="1"/>
+            </a:pPr>
+            <a:r>
+              <a:t>For sigma</a:t>
             </a:r>
           </a:p>
         </p:txBody>
       </p:sp>
       <p:pic>
         <p:nvPicPr>
-          <p:cNvPr id="3" name="Picture 2" descr="image-2.png"/>
+          <p:cNvPr id="3" name="Picture 2" descr="image-19.png"/>
           <p:cNvPicPr>
             <a:picLocks noChangeAspect="1"/>
           </p:cNvPicPr>
@@ -5790,8 +5682,8 @@
         </p:blipFill>
         <p:spPr>
           <a:xfrm>
-            <a:off x="914400" y="1097280"/>
-            <a:ext cx="10058400" cy="5029200"/>
+            <a:off x="365760" y="914400"/>
+            <a:ext cx="10972800" cy="2826608"/>
           </a:xfrm>
           <a:prstGeom prst="rect">
             <a:avLst/>
@@ -5824,8 +5716,8 @@
         </p:nvSpPr>
         <p:spPr>
           <a:xfrm>
-            <a:off x="457200" y="274320"/>
-            <a:ext cx="10972800" cy="731520"/>
+            <a:off x="365760" y="137160"/>
+            <a:ext cx="11430000" cy="640080"/>
           </a:xfrm>
           <a:prstGeom prst="rect">
             <a:avLst/>
@@ -5840,93 +5732,38 @@
           <a:p/>
           <a:p>
             <a:pPr>
-              <a:defRPr sz="3200" b="1"/>
-            </a:pPr>
-            <a:r>
-              <a:t>Toy Example — Optimizing Sigma</a:t>
-            </a:r>
-          </a:p>
-        </p:txBody>
-      </p:sp>
-      <p:sp>
-        <p:nvSpPr>
-          <p:cNvPr id="3" name="TextBox 2"/>
-          <p:cNvSpPr txBox="1"/>
-          <p:nvPr/>
-        </p:nvSpPr>
-        <p:spPr>
-          <a:xfrm>
-            <a:off x="457200" y="1188720"/>
-            <a:ext cx="10972800" cy="4572000"/>
-          </a:xfrm>
-          <a:prstGeom prst="rect">
-            <a:avLst/>
-          </a:prstGeom>
-          <a:noFill/>
-        </p:spPr>
-        <p:txBody>
-          <a:bodyPr wrap="none">
-            <a:spAutoFit/>
-          </a:bodyPr>
-          <a:lstStyle/>
-          <a:p/>
-          <a:p>
-            <a:pPr>
-              <a:spcAft>
-                <a:spcPts val="800"/>
-              </a:spcAft>
-              <a:defRPr sz="1800"/>
-            </a:pPr>
-            <a:r>
-              <a:t>Sample points from a Gaussian distribution</a:t>
-            </a:r>
-          </a:p>
-          <a:p>
-            <a:pPr>
-              <a:spcAft>
-                <a:spcPts val="800"/>
-              </a:spcAft>
-              <a:defRPr sz="1800"/>
-            </a:pPr>
-            <a:r>
-              <a:t>Square them, fit a pseudo-Voigt</a:t>
-            </a:r>
-          </a:p>
-          <a:p>
-            <a:pPr>
-              <a:spcAft>
-                <a:spcPts val="800"/>
-              </a:spcAft>
-              <a:defRPr sz="1800"/>
-            </a:pPr>
-            <a:r>
-              <a:t>Extract FWHM from the fit</a:t>
-            </a:r>
-          </a:p>
-          <a:p>
-            <a:pPr>
-              <a:spcAft>
-                <a:spcPts val="800"/>
-              </a:spcAft>
-              <a:defRPr sz="1800"/>
-            </a:pPr>
-            <a:r>
-              <a:t>Compare FWHM to a target and backpropagate</a:t>
-            </a:r>
-          </a:p>
-          <a:p>
-            <a:pPr>
-              <a:spcAft>
-                <a:spcPts val="800"/>
-              </a:spcAft>
-              <a:defRPr sz="1800"/>
-            </a:pPr>
-            <a:r>
-              <a:t>This tests: can we differentiate through a fit?</a:t>
-            </a:r>
-          </a:p>
-        </p:txBody>
-      </p:sp>
+              <a:defRPr sz="3600" b="1"/>
+            </a:pPr>
+            <a:r>
+              <a:t>For sigma</a:t>
+            </a:r>
+          </a:p>
+        </p:txBody>
+      </p:sp>
+      <p:pic>
+        <p:nvPicPr>
+          <p:cNvPr id="3" name="Picture 2" descr="image-20.png"/>
+          <p:cNvPicPr>
+            <a:picLocks noChangeAspect="1"/>
+          </p:cNvPicPr>
+          <p:nvPr/>
+        </p:nvPicPr>
+        <p:blipFill>
+          <a:blip r:embed="rId2"/>
+          <a:stretch>
+            <a:fillRect/>
+          </a:stretch>
+        </p:blipFill>
+        <p:spPr>
+          <a:xfrm>
+            <a:off x="365760" y="914400"/>
+            <a:ext cx="10972800" cy="6515857"/>
+          </a:xfrm>
+          <a:prstGeom prst="rect">
+            <a:avLst/>
+          </a:prstGeom>
+        </p:spPr>
+      </p:pic>
     </p:spTree>
   </p:cSld>
   <p:clrMapOvr>
@@ -5953,8 +5790,8 @@
         </p:nvSpPr>
         <p:spPr>
           <a:xfrm>
-            <a:off x="457200" y="274320"/>
-            <a:ext cx="10972800" cy="548640"/>
+            <a:off x="365760" y="137160"/>
+            <a:ext cx="11430000" cy="640080"/>
           </a:xfrm>
           <a:prstGeom prst="rect">
             <a:avLst/>
@@ -5969,17 +5806,17 @@
           <a:p/>
           <a:p>
             <a:pPr>
-              <a:defRPr sz="2800" b="1"/>
-            </a:pPr>
-            <a:r>
-              <a:t>Sigma Optimization — Setup</a:t>
+              <a:defRPr sz="3600" b="1"/>
+            </a:pPr>
+            <a:r>
+              <a:t>For sigma</a:t>
             </a:r>
           </a:p>
         </p:txBody>
       </p:sp>
       <p:pic>
         <p:nvPicPr>
-          <p:cNvPr id="3" name="Picture 2" descr="image-3.png"/>
+          <p:cNvPr id="3" name="Picture 2" descr="image-21.png"/>
           <p:cNvPicPr>
             <a:picLocks noChangeAspect="1"/>
           </p:cNvPicPr>
@@ -5993,8 +5830,8 @@
         </p:blipFill>
         <p:spPr>
           <a:xfrm>
-            <a:off x="914400" y="1097280"/>
-            <a:ext cx="10058400" cy="5029200"/>
+            <a:off x="365760" y="914400"/>
+            <a:ext cx="10972800" cy="4935092"/>
           </a:xfrm>
           <a:prstGeom prst="rect">
             <a:avLst/>
@@ -6027,8 +5864,8 @@
         </p:nvSpPr>
         <p:spPr>
           <a:xfrm>
-            <a:off x="457200" y="274320"/>
-            <a:ext cx="10972800" cy="548640"/>
+            <a:off x="365760" y="137160"/>
+            <a:ext cx="11430000" cy="640080"/>
           </a:xfrm>
           <a:prstGeom prst="rect">
             <a:avLst/>
@@ -6043,17 +5880,17 @@
           <a:p/>
           <a:p>
             <a:pPr>
-              <a:defRPr sz="2800" b="1"/>
-            </a:pPr>
-            <a:r>
-              <a:t>Sigma Optimization — Results</a:t>
+              <a:defRPr sz="3600" b="1"/>
+            </a:pPr>
+            <a:r>
+              <a:t>For sigma</a:t>
             </a:r>
           </a:p>
         </p:txBody>
       </p:sp>
       <p:pic>
         <p:nvPicPr>
-          <p:cNvPr id="3" name="Picture 2" descr="image-4.png"/>
+          <p:cNvPr id="3" name="Picture 2" descr="image-22.png"/>
           <p:cNvPicPr>
             <a:picLocks noChangeAspect="1"/>
           </p:cNvPicPr>
@@ -6067,8 +5904,8 @@
         </p:blipFill>
         <p:spPr>
           <a:xfrm>
-            <a:off x="914400" y="1097280"/>
-            <a:ext cx="10058400" cy="5029200"/>
+            <a:off x="365760" y="914400"/>
+            <a:ext cx="10972800" cy="4199176"/>
           </a:xfrm>
           <a:prstGeom prst="rect">
             <a:avLst/>

</xml_diff>